<commit_message>
Mapa de convenios de Algoria: Informe
</commit_message>
<xml_diff>
--- a/web/static/img/tema5/Tema5_ModeloPEV_breve.pptx
+++ b/web/static/img/tema5/Tema5_ModeloPEV_breve.pptx
@@ -11695,7 +11695,7 @@
         </p:blipFill>
         <p:spPr>
           <a:xfrm>
-            <a:off x="4718417" y="735963"/>
+            <a:off x="4856441" y="735963"/>
             <a:ext cx="869458" cy="869458"/>
           </a:xfrm>
           <a:prstGeom prst="rect">
@@ -11725,7 +11725,7 @@
         </p:blipFill>
         <p:spPr>
           <a:xfrm>
-            <a:off x="703291" y="714454"/>
+            <a:off x="841315" y="714454"/>
             <a:ext cx="829693" cy="829693"/>
           </a:xfrm>
           <a:prstGeom prst="rect">
@@ -11755,7 +11755,7 @@
         </p:blipFill>
         <p:spPr>
           <a:xfrm>
-            <a:off x="8871963" y="691559"/>
+            <a:off x="9009987" y="691559"/>
             <a:ext cx="869458" cy="869458"/>
           </a:xfrm>
           <a:prstGeom prst="rect">
@@ -11776,13 +11776,13 @@
           <p:nvPr>
             <p:extLst>
               <p:ext uri="{D42A27DB-BD31-4B8C-83A1-F6EECF244321}">
-                <p14:modId xmlns:p14="http://schemas.microsoft.com/office/powerpoint/2010/main" val="3852986236"/>
+                <p14:modId xmlns:p14="http://schemas.microsoft.com/office/powerpoint/2010/main" val="3737287278"/>
               </p:ext>
             </p:extLst>
           </p:nvPr>
         </p:nvGraphicFramePr>
         <p:xfrm>
-          <a:off x="-292646" y="520734"/>
+          <a:off x="-154622" y="520734"/>
           <a:ext cx="12312770" cy="4654591"/>
         </p:xfrm>
         <a:graphic>
@@ -11805,7 +11805,7 @@
         </p:nvSpPr>
         <p:spPr>
           <a:xfrm>
-            <a:off x="1054709" y="964186"/>
+            <a:off x="1192733" y="964186"/>
             <a:ext cx="10753219" cy="492443"/>
           </a:xfrm>
           <a:prstGeom prst="rect">
@@ -11878,7 +11878,7 @@
         </p:blipFill>
         <p:spPr>
           <a:xfrm>
-            <a:off x="8059947" y="1844569"/>
+            <a:off x="8197971" y="1844569"/>
             <a:ext cx="501769" cy="469900"/>
           </a:xfrm>
           <a:prstGeom prst="rect">
@@ -11902,7 +11902,7 @@
         </p:nvCxnSpPr>
         <p:spPr>
           <a:xfrm flipH="1">
-            <a:off x="1897811" y="4911017"/>
+            <a:off x="2035835" y="4911017"/>
             <a:ext cx="8281359" cy="0"/>
           </a:xfrm>
           <a:prstGeom prst="straightConnector1">
@@ -11941,7 +11941,7 @@
         </p:nvSpPr>
         <p:spPr>
           <a:xfrm>
-            <a:off x="3202816" y="4514498"/>
+            <a:off x="3340840" y="4514498"/>
             <a:ext cx="5321846" cy="707886"/>
           </a:xfrm>
           <a:prstGeom prst="rect">
@@ -11992,7 +11992,7 @@
         </p:nvCxnSpPr>
         <p:spPr>
           <a:xfrm flipV="1">
-            <a:off x="1897811" y="4278702"/>
+            <a:off x="2035835" y="4278702"/>
             <a:ext cx="0" cy="624245"/>
           </a:xfrm>
           <a:prstGeom prst="straightConnector1">
@@ -12033,7 +12033,7 @@
         </p:nvCxnSpPr>
         <p:spPr>
           <a:xfrm rot="10800000" flipV="1">
-            <a:off x="10176292" y="4256495"/>
+            <a:off x="10314316" y="4256495"/>
             <a:ext cx="0" cy="662400"/>
           </a:xfrm>
           <a:prstGeom prst="straightConnector1">

</xml_diff>